<commit_message>
style(ui): format phone numbers to senegal standard (XX XXX XX XX) and colorize action badges
</commit_message>
<xml_diff>
--- a/Presentation_Unikol_2026.pptx
+++ b/Presentation_Unikol_2026.pptx
@@ -4155,7 +4155,7 @@
               </a:spcAft>
             </a:pPr>
             <a:r>
-              <a:rPr sz="2600" b="1" i="0">
+              <a:rPr sz="1900" b="1" i="0">
                 <a:solidFill>
                   <a:srgbClr val="0F172A"/>
                 </a:solidFill>
@@ -4309,7 +4309,7 @@
               </a:spcAft>
             </a:pPr>
             <a:r>
-              <a:rPr sz="2600" b="1" i="0">
+              <a:rPr sz="1900" b="1" i="0">
                 <a:solidFill>
                   <a:srgbClr val="0F172A"/>
                 </a:solidFill>
@@ -4463,7 +4463,7 @@
               </a:spcAft>
             </a:pPr>
             <a:r>
-              <a:rPr sz="2600" b="1" i="0">
+              <a:rPr sz="1900" b="1" i="0">
                 <a:solidFill>
                   <a:srgbClr val="0F172A"/>
                 </a:solidFill>
@@ -4617,7 +4617,7 @@
               </a:spcAft>
             </a:pPr>
             <a:r>
-              <a:rPr sz="2600" b="1" i="0">
+              <a:rPr sz="1900" b="1" i="0">
                 <a:solidFill>
                   <a:srgbClr val="0F172A"/>
                 </a:solidFill>

</xml_diff>